<commit_message>
Revisionen Abb. 3.1, 3.23, 3.44
Co-Authored-By: Claude Sonnet 5.5 <noreply@anthropic.com>
Claude-Session: https://claude.ai/code/session_014sHYniGmpTAYgxNRSh3F5A
</commit_message>
<xml_diff>
--- a/abbildungen/kap3/Gesamtmodellueberblick_fuer_die_integrierte_Unternehmensplanung_und_-steuerung.pptx
+++ b/abbildungen/kap3/Gesamtmodellueberblick_fuer_die_integrierte_Unternehmensplanung_und_-steuerung.pptx
@@ -4953,7 +4953,7 @@
                 </a:solidFill>
                 <a:latin typeface="Arial"/>
               </a:rPr>
-              <a:t>Strategischem Ziel je Perspektive:</a:t>
+              <a:t>Strategische Ziele je Perspektive:</a:t>
             </a:r>
           </a:p>
           <a:p>
@@ -5084,7 +5084,7 @@
         </p:nvSpPr>
         <p:spPr>
           <a:xfrm>
-            <a:off x="2160000" y="1908000"/>
+            <a:off x="2160000" y="2120400"/>
             <a:ext cx="1965600" cy="1360800"/>
           </a:xfrm>
           <a:prstGeom prst="roundRect">
@@ -5115,7 +5115,7 @@
         </p:nvSpPr>
         <p:spPr>
           <a:xfrm>
-            <a:off x="2250000" y="1980000"/>
+            <a:off x="2250000" y="2192400"/>
             <a:ext cx="633600" cy="151200"/>
           </a:xfrm>
           <a:prstGeom prst="roundRect">
@@ -5165,7 +5165,7 @@
         </p:nvSpPr>
         <p:spPr>
           <a:xfrm>
-            <a:off x="2250000" y="2246400"/>
+            <a:off x="2250000" y="2458800"/>
             <a:ext cx="633600" cy="151200"/>
           </a:xfrm>
           <a:prstGeom prst="roundRect">
@@ -5215,7 +5215,7 @@
         </p:nvSpPr>
         <p:spPr>
           <a:xfrm>
-            <a:off x="2250000" y="2512800"/>
+            <a:off x="2250000" y="2725200"/>
             <a:ext cx="633600" cy="151200"/>
           </a:xfrm>
           <a:prstGeom prst="roundRect">
@@ -5265,7 +5265,7 @@
         </p:nvSpPr>
         <p:spPr>
           <a:xfrm>
-            <a:off x="2250000" y="2779200"/>
+            <a:off x="2250000" y="2991600"/>
             <a:ext cx="633600" cy="151200"/>
           </a:xfrm>
           <a:prstGeom prst="roundRect">
@@ -5315,7 +5315,7 @@
         </p:nvSpPr>
         <p:spPr>
           <a:xfrm>
-            <a:off x="2250000" y="3045600"/>
+            <a:off x="2250000" y="3258000"/>
             <a:ext cx="633600" cy="151200"/>
           </a:xfrm>
           <a:prstGeom prst="roundRect">
@@ -5365,7 +5365,7 @@
         </p:nvSpPr>
         <p:spPr>
           <a:xfrm>
-            <a:off x="3009600" y="2246400"/>
+            <a:off x="3009600" y="2458800"/>
             <a:ext cx="525600" cy="151200"/>
           </a:xfrm>
           <a:prstGeom prst="roundRect">
@@ -5415,7 +5415,7 @@
         </p:nvSpPr>
         <p:spPr>
           <a:xfrm>
-            <a:off x="3625200" y="2548800"/>
+            <a:off x="3625200" y="2761200"/>
             <a:ext cx="446400" cy="151200"/>
           </a:xfrm>
           <a:prstGeom prst="roundRect">
@@ -5465,7 +5465,7 @@
         </p:nvSpPr>
         <p:spPr>
           <a:xfrm>
-            <a:off x="2566800" y="2131200"/>
+            <a:off x="2566800" y="2343600"/>
             <a:ext cx="0" cy="115200"/>
           </a:xfrm>
           <a:custGeom>
@@ -5511,7 +5511,7 @@
         </p:nvSpPr>
         <p:spPr>
           <a:xfrm>
-            <a:off x="2566800" y="2664000"/>
+            <a:off x="2566800" y="2876400"/>
             <a:ext cx="0" cy="115200"/>
           </a:xfrm>
           <a:custGeom>
@@ -5557,7 +5557,7 @@
         </p:nvSpPr>
         <p:spPr>
           <a:xfrm>
-            <a:off x="2566800" y="2930400"/>
+            <a:off x="2566800" y="3142800"/>
             <a:ext cx="0" cy="115200"/>
           </a:xfrm>
           <a:custGeom>
@@ -5603,7 +5603,7 @@
         </p:nvSpPr>
         <p:spPr>
           <a:xfrm>
-            <a:off x="2203200" y="2055600"/>
+            <a:off x="2203200" y="2268000"/>
             <a:ext cx="46800" cy="532800"/>
           </a:xfrm>
           <a:custGeom>
@@ -5654,7 +5654,7 @@
         </p:nvSpPr>
         <p:spPr>
           <a:xfrm>
-            <a:off x="2883600" y="2322000"/>
+            <a:off x="2883600" y="2534400"/>
             <a:ext cx="126000" cy="0"/>
           </a:xfrm>
           <a:custGeom>
@@ -5699,7 +5699,7 @@
         </p:nvSpPr>
         <p:spPr>
           <a:xfrm>
-            <a:off x="2883600" y="2397600"/>
+            <a:off x="2883600" y="2610000"/>
             <a:ext cx="280800" cy="154800"/>
           </a:xfrm>
           <a:custGeom>
@@ -5747,7 +5747,7 @@
         </p:nvSpPr>
         <p:spPr>
           <a:xfrm>
-            <a:off x="2883600" y="2624400"/>
+            <a:off x="2883600" y="2836800"/>
             <a:ext cx="741600" cy="0"/>
           </a:xfrm>
           <a:custGeom>
@@ -5792,7 +5792,7 @@
         </p:nvSpPr>
         <p:spPr>
           <a:xfrm>
-            <a:off x="2883600" y="2397600"/>
+            <a:off x="2883600" y="2610000"/>
             <a:ext cx="496800" cy="723600"/>
           </a:xfrm>
           <a:custGeom>
@@ -5840,7 +5840,7 @@
         </p:nvSpPr>
         <p:spPr>
           <a:xfrm>
-            <a:off x="3535200" y="2322000"/>
+            <a:off x="3535200" y="2534400"/>
             <a:ext cx="313200" cy="226800"/>
           </a:xfrm>
           <a:custGeom>
@@ -6283,7 +6283,7 @@
         <p:spPr>
           <a:xfrm>
             <a:off x="1296000" y="1800000"/>
-            <a:ext cx="864000" cy="1252800"/>
+            <a:ext cx="864000" cy="1465200"/>
           </a:xfrm>
           <a:custGeom>
             <a:avLst/>
@@ -6292,15 +6292,15 @@
             <a:cxnLst/>
             <a:rect l="l" t="t" r="r" b="b"/>
             <a:pathLst>
-              <a:path w="864000" h="1252800">
+              <a:path w="864000" h="1465200">
                 <a:moveTo>
                   <a:pt x="0" y="0"/>
                 </a:moveTo>
                 <a:lnTo>
-                  <a:pt x="0" y="1252800"/>
+                  <a:pt x="0" y="1465200"/>
                 </a:lnTo>
                 <a:lnTo>
-                  <a:pt x="864000" y="1252800"/>
+                  <a:pt x="864000" y="1465200"/>
                 </a:lnTo>
               </a:path>
             </a:pathLst>
@@ -6330,7 +6330,7 @@
         </p:nvSpPr>
         <p:spPr>
           <a:xfrm>
-            <a:off x="1317600" y="2404800"/>
+            <a:off x="1317600" y="2617200"/>
             <a:ext cx="828000" cy="630000"/>
           </a:xfrm>
           <a:prstGeom prst="rect">
@@ -6425,7 +6425,7 @@
         <p:spPr>
           <a:xfrm>
             <a:off x="4125600" y="1800000"/>
-            <a:ext cx="320400" cy="288000"/>
+            <a:ext cx="320400" cy="500400"/>
           </a:xfrm>
           <a:custGeom>
             <a:avLst/>
@@ -6434,15 +6434,15 @@
             <a:cxnLst/>
             <a:rect l="l" t="t" r="r" b="b"/>
             <a:pathLst>
-              <a:path w="320400" h="288000">
+              <a:path w="320400" h="500400">
                 <a:moveTo>
                   <a:pt x="320400" y="0"/>
                 </a:moveTo>
                 <a:lnTo>
-                  <a:pt x="320400" y="288000"/>
+                  <a:pt x="320400" y="500400"/>
                 </a:lnTo>
                 <a:lnTo>
-                  <a:pt x="0" y="288000"/>
+                  <a:pt x="0" y="500400"/>
                 </a:lnTo>
               </a:path>
             </a:pathLst>
@@ -6473,7 +6473,7 @@
         <p:spPr>
           <a:xfrm>
             <a:off x="4482000" y="1818000"/>
-            <a:ext cx="612000" cy="252000"/>
+            <a:ext cx="612000" cy="464400"/>
           </a:xfrm>
           <a:prstGeom prst="rect">
             <a:avLst/>
@@ -6513,7 +6513,7 @@
         <p:spPr>
           <a:xfrm>
             <a:off x="4125600" y="1800000"/>
-            <a:ext cx="968400" cy="1360800"/>
+            <a:ext cx="968400" cy="1573200"/>
           </a:xfrm>
           <a:custGeom>
             <a:avLst/>
@@ -6522,12 +6522,12 @@
             <a:cxnLst/>
             <a:rect l="l" t="t" r="r" b="b"/>
             <a:pathLst>
-              <a:path w="968400" h="1360800">
+              <a:path w="968400" h="1573200">
                 <a:moveTo>
-                  <a:pt x="0" y="1360800"/>
+                  <a:pt x="0" y="1573200"/>
                 </a:moveTo>
                 <a:lnTo>
-                  <a:pt x="968400" y="1360800"/>
+                  <a:pt x="968400" y="1573200"/>
                 </a:lnTo>
                 <a:lnTo>
                   <a:pt x="968400" y="0"/>
@@ -6560,7 +6560,7 @@
         </p:nvSpPr>
         <p:spPr>
           <a:xfrm>
-            <a:off x="4161600" y="2930400"/>
+            <a:off x="4161600" y="3142800"/>
             <a:ext cx="918000" cy="223200"/>
           </a:xfrm>
           <a:prstGeom prst="rect">

</xml_diff>